<commit_message>
rename "Metadata" tab to "More" tab, update some icons
</commit_message>
<xml_diff>
--- a/spectroview/resources/icons/icon.pptx
+++ b/spectroview/resources/icons/icon.pptx
@@ -263,7 +263,7 @@
           <a:p>
             <a:fld id="{B9739118-5D76-D243-9607-339F9C0D3323}" type="datetimeFigureOut">
               <a:rPr lang="en-US" smtClean="0"/>
-              <a:t>2/11/2026</a:t>
+              <a:t>2/25/2026</a:t>
             </a:fld>
             <a:endParaRPr lang="en-US"/>
           </a:p>
@@ -461,7 +461,7 @@
           <a:p>
             <a:fld id="{B9739118-5D76-D243-9607-339F9C0D3323}" type="datetimeFigureOut">
               <a:rPr lang="en-US" smtClean="0"/>
-              <a:t>2/11/2026</a:t>
+              <a:t>2/25/2026</a:t>
             </a:fld>
             <a:endParaRPr lang="en-US"/>
           </a:p>
@@ -669,7 +669,7 @@
           <a:p>
             <a:fld id="{B9739118-5D76-D243-9607-339F9C0D3323}" type="datetimeFigureOut">
               <a:rPr lang="en-US" smtClean="0"/>
-              <a:t>2/11/2026</a:t>
+              <a:t>2/25/2026</a:t>
             </a:fld>
             <a:endParaRPr lang="en-US"/>
           </a:p>
@@ -867,7 +867,7 @@
           <a:p>
             <a:fld id="{B9739118-5D76-D243-9607-339F9C0D3323}" type="datetimeFigureOut">
               <a:rPr lang="en-US" smtClean="0"/>
-              <a:t>2/11/2026</a:t>
+              <a:t>2/25/2026</a:t>
             </a:fld>
             <a:endParaRPr lang="en-US"/>
           </a:p>
@@ -1142,7 +1142,7 @@
           <a:p>
             <a:fld id="{B9739118-5D76-D243-9607-339F9C0D3323}" type="datetimeFigureOut">
               <a:rPr lang="en-US" smtClean="0"/>
-              <a:t>2/11/2026</a:t>
+              <a:t>2/25/2026</a:t>
             </a:fld>
             <a:endParaRPr lang="en-US"/>
           </a:p>
@@ -1407,7 +1407,7 @@
           <a:p>
             <a:fld id="{B9739118-5D76-D243-9607-339F9C0D3323}" type="datetimeFigureOut">
               <a:rPr lang="en-US" smtClean="0"/>
-              <a:t>2/11/2026</a:t>
+              <a:t>2/25/2026</a:t>
             </a:fld>
             <a:endParaRPr lang="en-US"/>
           </a:p>
@@ -1819,7 +1819,7 @@
           <a:p>
             <a:fld id="{B9739118-5D76-D243-9607-339F9C0D3323}" type="datetimeFigureOut">
               <a:rPr lang="en-US" smtClean="0"/>
-              <a:t>2/11/2026</a:t>
+              <a:t>2/25/2026</a:t>
             </a:fld>
             <a:endParaRPr lang="en-US"/>
           </a:p>
@@ -1960,7 +1960,7 @@
           <a:p>
             <a:fld id="{B9739118-5D76-D243-9607-339F9C0D3323}" type="datetimeFigureOut">
               <a:rPr lang="en-US" smtClean="0"/>
-              <a:t>2/11/2026</a:t>
+              <a:t>2/25/2026</a:t>
             </a:fld>
             <a:endParaRPr lang="en-US"/>
           </a:p>
@@ -2073,7 +2073,7 @@
           <a:p>
             <a:fld id="{B9739118-5D76-D243-9607-339F9C0D3323}" type="datetimeFigureOut">
               <a:rPr lang="en-US" smtClean="0"/>
-              <a:t>2/11/2026</a:t>
+              <a:t>2/25/2026</a:t>
             </a:fld>
             <a:endParaRPr lang="en-US"/>
           </a:p>
@@ -2384,7 +2384,7 @@
           <a:p>
             <a:fld id="{B9739118-5D76-D243-9607-339F9C0D3323}" type="datetimeFigureOut">
               <a:rPr lang="en-US" smtClean="0"/>
-              <a:t>2/11/2026</a:t>
+              <a:t>2/25/2026</a:t>
             </a:fld>
             <a:endParaRPr lang="en-US"/>
           </a:p>
@@ -2672,7 +2672,7 @@
           <a:p>
             <a:fld id="{B9739118-5D76-D243-9607-339F9C0D3323}" type="datetimeFigureOut">
               <a:rPr lang="en-US" smtClean="0"/>
-              <a:t>2/11/2026</a:t>
+              <a:t>2/25/2026</a:t>
             </a:fld>
             <a:endParaRPr lang="en-US"/>
           </a:p>
@@ -2913,7 +2913,7 @@
           <a:p>
             <a:fld id="{B9739118-5D76-D243-9607-339F9C0D3323}" type="datetimeFigureOut">
               <a:rPr lang="en-US" smtClean="0"/>
-              <a:t>2/11/2026</a:t>
+              <a:t>2/25/2026</a:t>
             </a:fld>
             <a:endParaRPr lang="en-US"/>
           </a:p>
@@ -4837,7 +4837,10 @@
             <a:noFill/>
             <a:ln w="57150">
               <a:solidFill>
-                <a:srgbClr val="00B050"/>
+                <a:schemeClr val="tx2">
+                  <a:lumMod val="50000"/>
+                  <a:lumOff val="50000"/>
+                </a:schemeClr>
               </a:solidFill>
             </a:ln>
           </p:spPr>
@@ -4947,7 +4950,10 @@
             <a:noFill/>
             <a:ln w="57150">
               <a:solidFill>
-                <a:srgbClr val="C00000"/>
+                <a:schemeClr val="accent5">
+                  <a:lumMod val="60000"/>
+                  <a:lumOff val="40000"/>
+                </a:schemeClr>
               </a:solidFill>
             </a:ln>
           </p:spPr>
@@ -5121,6 +5127,60 @@
           </p:txBody>
         </p:sp>
       </p:grpSp>
+      <p:pic>
+        <p:nvPicPr>
+          <p:cNvPr id="31" name="Picture 2" descr="Github - Free logo icons">
+            <a:extLst>
+              <a:ext uri="{FF2B5EF4-FFF2-40B4-BE49-F238E27FC236}">
+                <a16:creationId xmlns:a16="http://schemas.microsoft.com/office/drawing/2014/main" id="{1B9C0365-C0A3-4773-ACE8-3DC30D283744}"/>
+              </a:ext>
+            </a:extLst>
+          </p:cNvPr>
+          <p:cNvPicPr>
+            <a:picLocks noChangeAspect="1" noChangeArrowheads="1"/>
+          </p:cNvPicPr>
+          <p:nvPr/>
+        </p:nvPicPr>
+        <p:blipFill>
+          <a:blip r:embed="rId3">
+            <a:duotone>
+              <a:schemeClr val="accent4">
+                <a:shade val="45000"/>
+                <a:satMod val="135000"/>
+              </a:schemeClr>
+              <a:prstClr val="white"/>
+            </a:duotone>
+            <a:extLst>
+              <a:ext uri="{28A0092B-C50C-407E-A947-70E740481C1C}">
+                <a14:useLocalDpi xmlns:a14="http://schemas.microsoft.com/office/drawing/2010/main" val="0"/>
+              </a:ext>
+            </a:extLst>
+          </a:blip>
+          <a:srcRect/>
+          <a:stretch>
+            <a:fillRect/>
+          </a:stretch>
+        </p:blipFill>
+        <p:spPr bwMode="auto">
+          <a:xfrm>
+            <a:off x="9135065" y="2494327"/>
+            <a:ext cx="2088651" cy="2088651"/>
+          </a:xfrm>
+          <a:prstGeom prst="rect">
+            <a:avLst/>
+          </a:prstGeom>
+          <a:noFill/>
+          <a:extLst>
+            <a:ext uri="{909E8E84-426E-40DD-AFC4-6F175D3DCCD1}">
+              <a14:hiddenFill xmlns:a14="http://schemas.microsoft.com/office/drawing/2010/main">
+                <a:solidFill>
+                  <a:srgbClr val="FFFFFF"/>
+                </a:solidFill>
+              </a14:hiddenFill>
+            </a:ext>
+          </a:extLst>
+        </p:spPr>
+      </p:pic>
     </p:spTree>
     <p:extLst>
       <p:ext uri="{BB962C8B-B14F-4D97-AF65-F5344CB8AC3E}">

</xml_diff>